<commit_message>
Complete verified local agent and hackathon presentation
</commit_message>
<xml_diff>
--- a/submission/traceharbor.pptx
+++ b/submission/traceharbor.pptx
@@ -2,20 +2,20 @@
 <file path=ppt/presentation.xml><?xml version="1.0" encoding="utf-8"?>
 <p:presentation xmlns:p="http://schemas.openxmlformats.org/presentationml/2006/main">
   <p:sldMasterIdLst>
-    <p:sldMasterId xmlns:r="http://schemas.openxmlformats.org/officeDocument/2006/relationships" id="2147483648" r:id="Rc288210426ed4f69"/>
+    <p:sldMasterId xmlns:r="http://schemas.openxmlformats.org/officeDocument/2006/relationships" id="2147483648" r:id="Raded46a237d84aff"/>
   </p:sldMasterIdLst>
   <p:notesMasterIdLst>
-    <p:notesMasterId xmlns:r="http://schemas.openxmlformats.org/officeDocument/2006/relationships" r:id="R48f3f7d0bd924a3d"/>
+    <p:notesMasterId xmlns:r="http://schemas.openxmlformats.org/officeDocument/2006/relationships" r:id="Ref1d848cbe8a482c"/>
   </p:notesMasterIdLst>
   <p:sldIdLst>
-    <p:sldId xmlns:r="http://schemas.openxmlformats.org/officeDocument/2006/relationships" id="256" r:id="Rf619aa86473547ea"/>
-    <p:sldId xmlns:r="http://schemas.openxmlformats.org/officeDocument/2006/relationships" id="257" r:id="R91fb8725f1834cb8"/>
-    <p:sldId xmlns:r="http://schemas.openxmlformats.org/officeDocument/2006/relationships" id="258" r:id="R8603e0c9a664488e"/>
-    <p:sldId xmlns:r="http://schemas.openxmlformats.org/officeDocument/2006/relationships" id="259" r:id="Rd811b9b8a394439a"/>
-    <p:sldId xmlns:r="http://schemas.openxmlformats.org/officeDocument/2006/relationships" id="260" r:id="R5bde0719d8a2485c"/>
-    <p:sldId xmlns:r="http://schemas.openxmlformats.org/officeDocument/2006/relationships" id="261" r:id="R790d27b94f0743d8"/>
-    <p:sldId xmlns:r="http://schemas.openxmlformats.org/officeDocument/2006/relationships" id="262" r:id="Rc88bafda892b4694"/>
-    <p:sldId xmlns:r="http://schemas.openxmlformats.org/officeDocument/2006/relationships" id="263" r:id="R84816f22a1c84bf0"/>
+    <p:sldId xmlns:r="http://schemas.openxmlformats.org/officeDocument/2006/relationships" id="256" r:id="R3b96aa413b604062"/>
+    <p:sldId xmlns:r="http://schemas.openxmlformats.org/officeDocument/2006/relationships" id="257" r:id="R950c419de0024125"/>
+    <p:sldId xmlns:r="http://schemas.openxmlformats.org/officeDocument/2006/relationships" id="258" r:id="R7c8a9f9226784ba8"/>
+    <p:sldId xmlns:r="http://schemas.openxmlformats.org/officeDocument/2006/relationships" id="259" r:id="R8360a59ee5734022"/>
+    <p:sldId xmlns:r="http://schemas.openxmlformats.org/officeDocument/2006/relationships" id="260" r:id="Rd3dd037dd75e4338"/>
+    <p:sldId xmlns:r="http://schemas.openxmlformats.org/officeDocument/2006/relationships" id="261" r:id="R00f3003e88384bc6"/>
+    <p:sldId xmlns:r="http://schemas.openxmlformats.org/officeDocument/2006/relationships" id="262" r:id="Rd99802f459c54eda"/>
+    <p:sldId xmlns:r="http://schemas.openxmlformats.org/officeDocument/2006/relationships" id="263" r:id="R9eb670720443476e"/>
   </p:sldIdLst>
   <p:sldSz cx="12192000" cy="6858000"/>
   <p:notesSz cx="6858000" cy="9144000"/>
@@ -559,7 +559,7 @@
           </a:p>
           <a:p xmlns:a="http://schemas.openxmlformats.org/drawingml/2006/main">
             <a:r>
-              <a:t>docs/images/traceharbor-desktop.png</a:t>
+              <a:t>docs/images/video/01-overview.png</a:t>
             </a:r>
           </a:p>
           <a:p xmlns:a="http://schemas.openxmlformats.org/drawingml/2006/main">
@@ -634,7 +634,7 @@
           <a:lstStyle xmlns:a="http://schemas.openxmlformats.org/drawingml/2006/main"/>
           <a:p xmlns:a="http://schemas.openxmlformats.org/drawingml/2006/main">
             <a:r>
-              <a:t>This slide describes the implemented live path, not a successful sponsor-model run. Planner and critic choices are restricted to allowlisted evidence operations. The deterministic core owns temperature arithmetic and verdicts. The live orchestrator must stop on transport errors and never silently fall back to the sample dataset. Verify the current implementation and corresponding tests before presenting.</a:t>
+              <a:t>The complete live path is verified by examples/live-agent/attempt-03-browser/manifest.json, run traceharbor-f819006a-6108-4019-a59f-3e90326edbeb. The planner chooses two or three initial sources. The critic can retrieve omitted evidence, recompute the factual result, and select an evidence-withholding challenge. The deterministic core owns temperature arithmetic and verdicts. Transport errors remain explicit; there is no silent sample fallback.</a:t>
             </a:r>
           </a:p>
           <a:p xmlns:a="http://schemas.openxmlformats.org/drawingml/2006/main">
@@ -665,6 +665,11 @@
           <a:p xmlns:a="http://schemas.openxmlformats.org/drawingml/2006/main">
             <a:r>
               <a:t>docs/architecture.md</a:t>
+            </a:r>
+          </a:p>
+          <a:p xmlns:a="http://schemas.openxmlformats.org/drawingml/2006/main">
+            <a:r>
+              <a:t>examples/live-agent/attempt-03-browser/manifest.json</a:t>
             </a:r>
           </a:p>
         </p:txBody>
@@ -734,7 +739,7 @@
           <a:lstStyle xmlns:a="http://schemas.openxmlformats.org/drawingml/2006/main"/>
           <a:p xmlns:a="http://schemas.openxmlformats.org/drawingml/2006/main">
             <a:r>
-              <a:t>The website is deployed and independently verified with four feeds and the evidence-withholding interaction. The public frontend cannot access the builder’s loopback services. The local companion serves the built frontend and a bounded same-origin investigation API. No service tokens are embedded in the frontend bundle.</a:t>
+              <a:t>The website is deployed and independently verified with four feeds and the evidence-withholding interaction. The public frontend cannot access loopback services on the development computer. The local companion serves the built frontend and a bounded same-origin investigation API. No service tokens are embedded in the frontend bundle.</a:t>
             </a:r>
           </a:p>
           <a:p xmlns:a="http://schemas.openxmlformats.org/drawingml/2006/main">
@@ -839,7 +844,7 @@
           <a:lstStyle xmlns:a="http://schemas.openxmlformats.org/drawingml/2006/main"/>
           <a:p xmlns:a="http://schemas.openxmlformats.org/drawingml/2006/main">
             <a:r>
-              <a:t>This status is deliberately evidence bounded. The official World Model is vendored at revision 1742dec56a66e58eef9dda2d2b865823758ca8cd with its Apache-2.0 license retained. Its upstream conformance runner passed eight of eight. At this build, Nightshift is installed and authenticated models discovery succeeds, but a real completion returns no_provider_configured. Update only after actual successful receipts exist. Network-mocked orchestration tests do not count as sponsor execution.</a:t>
+              <a:t>The official World Model is vendored at revision 1742dec56a66e58eef9dda2d2b865823758ca8cd with its Apache-2.0 license retained; eight upstream conformance checks passed. Actual Zetaris receipts cover four REST sources, twelve exploration queries, USL activation, and data quality: 26 telemetry rows, 25 valid and one invalid. The complete live manifest records three Nightshift requests and 4 Zetaris reads. Returned models: local-runtime/llama-3.2-1b-instruct. Automated mocked transports are not sponsor-execution proof. No NVIDIA cloud or Nemotron use is claimed.</a:t>
             </a:r>
           </a:p>
           <a:p xmlns:a="http://schemas.openxmlformats.org/drawingml/2006/main">
@@ -859,17 +864,22 @@
           </a:p>
           <a:p xmlns:a="http://schemas.openxmlformats.org/drawingml/2006/main">
             <a:r>
+              <a:t>examples/live-zetaris/README.md</a:t>
+            </a:r>
+          </a:p>
+          <a:p xmlns:a="http://schemas.openxmlformats.org/drawingml/2006/main">
+            <a:r>
+              <a:t>examples/live-nightshift-preflight/receipt.json</a:t>
+            </a:r>
+          </a:p>
+          <a:p xmlns:a="http://schemas.openxmlformats.org/drawingml/2006/main">
+            <a:r>
               <a:t>core/vendor/meterless-world-model/UPSTREAM.md</a:t>
             </a:r>
           </a:p>
           <a:p xmlns:a="http://schemas.openxmlformats.org/drawingml/2006/main">
             <a:r>
-              <a:t>docs/sponsor-technology.md</a:t>
-            </a:r>
-          </a:p>
-          <a:p xmlns:a="http://schemas.openxmlformats.org/drawingml/2006/main">
-            <a:r>
-              <a:t>https://github.com/Meterless/Meterless</a:t>
+              <a:t>examples/live-agent/attempt-03-browser/manifest.json</a:t>
             </a:r>
           </a:p>
         </p:txBody>
@@ -959,7 +969,7 @@
           </a:p>
           <a:p xmlns:a="http://schemas.openxmlformats.org/drawingml/2006/main">
             <a:r>
-              <a:t>docs/images/calibration-counterfactual.png</a:t>
+              <a:t>docs/images/video/05-calibration-withheld.png</a:t>
             </a:r>
           </a:p>
           <a:p xmlns:a="http://schemas.openxmlformats.org/drawingml/2006/main">
@@ -1221,7 +1231,7 @@
           <p:cNvPr id="3" name="Title">
             <a:extLst xmlns:a="http://schemas.openxmlformats.org/drawingml/2006/main">
               <a:ext uri="{FF2B5EF4-FFF2-40B4-BE49-F238E27FC236}">
-                <a16:creationId xmlns:a16="http://schemas.microsoft.com/office/drawing/2014/main" id="{553B3B34-7B89-442A-9487-4333E7F02E46}"/>
+                <a16:creationId xmlns:a16="http://schemas.microsoft.com/office/drawing/2014/main" id="{71CDC2E8-5D85-4969-A106-5A3955C4D026}"/>
               </a:ext>
             </a:extLst>
           </p:cNvPr>
@@ -1450,7 +1460,7 @@
           <p:cNvPr id="2" name="Subtitle">
             <a:extLst xmlns:a="http://schemas.openxmlformats.org/drawingml/2006/main">
               <a:ext uri="{FF2B5EF4-FFF2-40B4-BE49-F238E27FC236}">
-                <a16:creationId xmlns:a16="http://schemas.microsoft.com/office/drawing/2014/main" id="{43B62D7A-1568-4AC9-BBF1-36B810E437FE}"/>
+                <a16:creationId xmlns:a16="http://schemas.microsoft.com/office/drawing/2014/main" id="{E9384C94-4CBC-4FEE-AC89-983B4DDD3731}"/>
               </a:ext>
             </a:extLst>
           </p:cNvPr>
@@ -1696,7 +1706,7 @@
           <p:cNvPr id="2" name="Section title">
             <a:extLst xmlns:a="http://schemas.openxmlformats.org/drawingml/2006/main">
               <a:ext uri="{FF2B5EF4-FFF2-40B4-BE49-F238E27FC236}">
-                <a16:creationId xmlns:a16="http://schemas.microsoft.com/office/drawing/2014/main" id="{DF10CC9E-D31A-4F88-ADA0-4572131FD445}"/>
+                <a16:creationId xmlns:a16="http://schemas.microsoft.com/office/drawing/2014/main" id="{AAED3241-BDEF-4623-B45E-972C134E3E90}"/>
               </a:ext>
             </a:extLst>
           </p:cNvPr>
@@ -1942,7 +1952,7 @@
           <p:cNvPr id="3" name="Title">
             <a:extLst xmlns:a="http://schemas.openxmlformats.org/drawingml/2006/main">
               <a:ext uri="{FF2B5EF4-FFF2-40B4-BE49-F238E27FC236}">
-                <a16:creationId xmlns:a16="http://schemas.microsoft.com/office/drawing/2014/main" id="{D8BC07BA-9066-439C-A12A-440BE79F4144}"/>
+                <a16:creationId xmlns:a16="http://schemas.microsoft.com/office/drawing/2014/main" id="{4C49781A-7DCF-4B34-88F4-F1A17AFA57C7}"/>
               </a:ext>
             </a:extLst>
           </p:cNvPr>
@@ -2171,7 +2181,7 @@
           <p:cNvPr id="2" name="Body">
             <a:extLst xmlns:a="http://schemas.openxmlformats.org/drawingml/2006/main">
               <a:ext uri="{FF2B5EF4-FFF2-40B4-BE49-F238E27FC236}">
-                <a16:creationId xmlns:a16="http://schemas.microsoft.com/office/drawing/2014/main" id="{5F5A9DA1-954D-4689-A6A3-D4186110F925}"/>
+                <a16:creationId xmlns:a16="http://schemas.microsoft.com/office/drawing/2014/main" id="{8CB25CB8-4321-4C42-A480-7BECFBAFED40}"/>
               </a:ext>
             </a:extLst>
           </p:cNvPr>
@@ -2417,7 +2427,7 @@
           <p:cNvPr id="4" name="Title">
             <a:extLst xmlns:a="http://schemas.openxmlformats.org/drawingml/2006/main">
               <a:ext uri="{FF2B5EF4-FFF2-40B4-BE49-F238E27FC236}">
-                <a16:creationId xmlns:a16="http://schemas.microsoft.com/office/drawing/2014/main" id="{81CA663C-127E-4288-8E30-5DD6FA15FACA}"/>
+                <a16:creationId xmlns:a16="http://schemas.microsoft.com/office/drawing/2014/main" id="{D4DC89C8-2401-4192-AC68-1F74E5F77150}"/>
               </a:ext>
             </a:extLst>
           </p:cNvPr>
@@ -2646,7 +2656,7 @@
           <p:cNvPr id="2" name="Left column">
             <a:extLst xmlns:a="http://schemas.openxmlformats.org/drawingml/2006/main">
               <a:ext uri="{FF2B5EF4-FFF2-40B4-BE49-F238E27FC236}">
-                <a16:creationId xmlns:a16="http://schemas.microsoft.com/office/drawing/2014/main" id="{C1DDF37A-B5E1-4AF1-AB57-2AEECD3B2896}"/>
+                <a16:creationId xmlns:a16="http://schemas.microsoft.com/office/drawing/2014/main" id="{14F25B0F-7729-4544-BE8C-1B40A28C9995}"/>
               </a:ext>
             </a:extLst>
           </p:cNvPr>
@@ -2875,7 +2885,7 @@
           <p:cNvPr id="3" name="Right column">
             <a:extLst xmlns:a="http://schemas.openxmlformats.org/drawingml/2006/main">
               <a:ext uri="{FF2B5EF4-FFF2-40B4-BE49-F238E27FC236}">
-                <a16:creationId xmlns:a16="http://schemas.microsoft.com/office/drawing/2014/main" id="{7866E4FF-A17A-46A4-96D4-9DAD3A878C21}"/>
+                <a16:creationId xmlns:a16="http://schemas.microsoft.com/office/drawing/2014/main" id="{D042211E-17C5-427D-BC60-DFD3135C1C36}"/>
               </a:ext>
             </a:extLst>
           </p:cNvPr>
@@ -3121,7 +3131,7 @@
           <p:cNvPr id="3" name="Title">
             <a:extLst xmlns:a="http://schemas.openxmlformats.org/drawingml/2006/main">
               <a:ext uri="{FF2B5EF4-FFF2-40B4-BE49-F238E27FC236}">
-                <a16:creationId xmlns:a16="http://schemas.microsoft.com/office/drawing/2014/main" id="{B7BB853B-0592-4E14-B6EF-6BBFA792AC67}"/>
+                <a16:creationId xmlns:a16="http://schemas.microsoft.com/office/drawing/2014/main" id="{5AFE71B2-89B7-4020-B89B-ABBF336E2DFF}"/>
               </a:ext>
             </a:extLst>
           </p:cNvPr>
@@ -3350,7 +3360,7 @@
           <p:cNvPr id="2" name="Left column">
             <a:extLst xmlns:a="http://schemas.openxmlformats.org/drawingml/2006/main">
               <a:ext uri="{FF2B5EF4-FFF2-40B4-BE49-F238E27FC236}">
-                <a16:creationId xmlns:a16="http://schemas.microsoft.com/office/drawing/2014/main" id="{21C67FFC-C53E-4ABD-98B5-470CAB441D6A}"/>
+                <a16:creationId xmlns:a16="http://schemas.microsoft.com/office/drawing/2014/main" id="{8F287CD7-71B5-424D-B327-45BD6EE6F16E}"/>
               </a:ext>
             </a:extLst>
           </p:cNvPr>
@@ -3617,12 +3627,12 @@
   </p:cSld>
   <p:clrMap bg1="lt1" tx1="dk1" bg2="lt2" tx2="dk2" accent1="accent1" accent2="accent2" accent3="accent3" accent4="accent4" accent5="accent5" accent6="accent6" hlink="hlink" folHlink="folHlink"/>
   <p:sldLayoutIdLst>
-    <p:sldLayoutId xmlns:r="http://schemas.openxmlformats.org/officeDocument/2006/relationships" id="2147483649" r:id="Rde64ca6c82ef47da"/>
-    <p:sldLayoutId xmlns:r="http://schemas.openxmlformats.org/officeDocument/2006/relationships" id="2147483650" r:id="Rf8b19dc68e984ca4"/>
-    <p:sldLayoutId xmlns:r="http://schemas.openxmlformats.org/officeDocument/2006/relationships" id="2147483651" r:id="R9b761a73d9504f7d"/>
-    <p:sldLayoutId xmlns:r="http://schemas.openxmlformats.org/officeDocument/2006/relationships" id="2147483652" r:id="Rc7e5152ce7d04016"/>
-    <p:sldLayoutId xmlns:r="http://schemas.openxmlformats.org/officeDocument/2006/relationships" id="2147483653" r:id="R5724b54c8af04166"/>
-    <p:sldLayoutId xmlns:r="http://schemas.openxmlformats.org/officeDocument/2006/relationships" id="2147483654" r:id="R9ce9df8665ed4a7d"/>
+    <p:sldLayoutId xmlns:r="http://schemas.openxmlformats.org/officeDocument/2006/relationships" id="2147483649" r:id="R5ec2a0121bc44a88"/>
+    <p:sldLayoutId xmlns:r="http://schemas.openxmlformats.org/officeDocument/2006/relationships" id="2147483650" r:id="R4a1063601ab043d5"/>
+    <p:sldLayoutId xmlns:r="http://schemas.openxmlformats.org/officeDocument/2006/relationships" id="2147483651" r:id="R7c79337388d84ae3"/>
+    <p:sldLayoutId xmlns:r="http://schemas.openxmlformats.org/officeDocument/2006/relationships" id="2147483652" r:id="R663c6ebd02864395"/>
+    <p:sldLayoutId xmlns:r="http://schemas.openxmlformats.org/officeDocument/2006/relationships" id="2147483653" r:id="R67432d0931234cc9"/>
+    <p:sldLayoutId xmlns:r="http://schemas.openxmlformats.org/officeDocument/2006/relationships" id="2147483654" r:id="Ra267c8247a2b45ed"/>
   </p:sldLayoutIdLst>
   <p:txStyles>
     <p:titleStyle>
@@ -4173,7 +4183,7 @@
           <p:cNvPr id="8" name="">
             <a:extLst xmlns:a="http://schemas.openxmlformats.org/drawingml/2006/main">
               <a:ext uri="{FF2B5EF4-FFF2-40B4-BE49-F238E27FC236}">
-                <a16:creationId xmlns:a16="http://schemas.microsoft.com/office/drawing/2014/main" id="{EE4B583C-1513-49C7-8BE7-2D964D646F4F}"/>
+                <a16:creationId xmlns:a16="http://schemas.microsoft.com/office/drawing/2014/main" id="{26C970EA-DEF6-4841-AB69-3933DEFD8D66}"/>
               </a:ext>
             </a:extLst>
           </p:cNvPr>
@@ -4319,7 +4329,7 @@
                 <a:ea typeface="Arial"/>
                 <a:cs typeface="Arial"/>
               </a:rPr>
-              <a:t>TRACK 2 · THE AGENT THAT CAN EXPLAIN WHY</a:t>
+              <a:t>TRACK 2 / THE AGENT THAT CAN EXPLAIN WHY</a:t>
             </a:r>
           </a:p>
         </p:txBody>
@@ -4329,7 +4339,7 @@
           <p:cNvPr id="2" name="">
             <a:extLst xmlns:a="http://schemas.openxmlformats.org/drawingml/2006/main">
               <a:ext uri="{FF2B5EF4-FFF2-40B4-BE49-F238E27FC236}">
-                <a16:creationId xmlns:a16="http://schemas.microsoft.com/office/drawing/2014/main" id="{D3DF24B2-5AA1-4E56-947C-42964E462F3F}"/>
+                <a16:creationId xmlns:a16="http://schemas.microsoft.com/office/drawing/2014/main" id="{7681123D-5B5C-43D0-B096-47625513D3CF}"/>
               </a:ext>
             </a:extLst>
           </p:cNvPr>
@@ -4485,7 +4495,7 @@
           <p:cNvPr id="3" name="">
             <a:extLst xmlns:a="http://schemas.openxmlformats.org/drawingml/2006/main">
               <a:ext uri="{FF2B5EF4-FFF2-40B4-BE49-F238E27FC236}">
-                <a16:creationId xmlns:a16="http://schemas.microsoft.com/office/drawing/2014/main" id="{BF344FDA-930B-4320-B8EE-BBAB978C3C3C}"/>
+                <a16:creationId xmlns:a16="http://schemas.microsoft.com/office/drawing/2014/main" id="{F509F252-7CAA-499C-AAC7-F4A77C5B53AF}"/>
               </a:ext>
             </a:extLst>
           </p:cNvPr>
@@ -4641,7 +4651,7 @@
           <p:cNvPr id="4" name="">
             <a:extLst xmlns:a="http://schemas.openxmlformats.org/drawingml/2006/main">
               <a:ext uri="{FF2B5EF4-FFF2-40B4-BE49-F238E27FC236}">
-                <a16:creationId xmlns:a16="http://schemas.microsoft.com/office/drawing/2014/main" id="{42914A54-F35A-49D0-91A4-64913CAE491C}"/>
+                <a16:creationId xmlns:a16="http://schemas.microsoft.com/office/drawing/2014/main" id="{83BAEAB5-5012-4E76-B56E-312FEB0FA3A7}"/>
               </a:ext>
             </a:extLst>
           </p:cNvPr>
@@ -4797,7 +4807,7 @@
           <p:cNvPr id="5" name="">
             <a:extLst xmlns:a="http://schemas.openxmlformats.org/drawingml/2006/main">
               <a:ext uri="{FF2B5EF4-FFF2-40B4-BE49-F238E27FC236}">
-                <a16:creationId xmlns:a16="http://schemas.microsoft.com/office/drawing/2014/main" id="{21D88518-E1A7-4BCC-A079-C062C089AEDB}"/>
+                <a16:creationId xmlns:a16="http://schemas.microsoft.com/office/drawing/2014/main" id="{E8CC9169-DBF9-40FF-87CB-AF1EFD172B3C}"/>
               </a:ext>
             </a:extLst>
           </p:cNvPr>
@@ -4976,7 +4986,7 @@
           <p:cNvPr id="6" name="">
             <a:extLst xmlns:a="http://schemas.openxmlformats.org/drawingml/2006/main">
               <a:ext uri="{FF2B5EF4-FFF2-40B4-BE49-F238E27FC236}">
-                <a16:creationId xmlns:a16="http://schemas.microsoft.com/office/drawing/2014/main" id="{2DDFD6B4-51FE-4774-B8DB-4846A68D030A}"/>
+                <a16:creationId xmlns:a16="http://schemas.microsoft.com/office/drawing/2014/main" id="{2D634441-99DD-43F8-98BA-CE99A6BD60A4}"/>
               </a:ext>
             </a:extLst>
           </p:cNvPr>
@@ -5155,7 +5165,7 @@
           <p:cNvPr id="7" name="">
             <a:extLst xmlns:a="http://schemas.openxmlformats.org/drawingml/2006/main">
               <a:ext uri="{FF2B5EF4-FFF2-40B4-BE49-F238E27FC236}">
-                <a16:creationId xmlns:a16="http://schemas.microsoft.com/office/drawing/2014/main" id="{BB1E910E-417A-4A6C-8BFF-85A8BB2ADE8C}"/>
+                <a16:creationId xmlns:a16="http://schemas.microsoft.com/office/drawing/2014/main" id="{F797C1DF-D920-4AFF-BD75-CE31F1C05FBF}"/>
               </a:ext>
             </a:extLst>
           </p:cNvPr>
@@ -5301,7 +5311,7 @@
                 <a:ea typeface="Arial"/>
                 <a:cs typeface="Arial"/>
               </a:rPr>
-              <a:t>MANIFEST  ·  TELEMETRY  ·  INCIDENTS  ·  CALIBRATION</a:t>
+              <a:t>MANIFEST  /  TELEMETRY  /  INCIDENTS  /  CALIBRATION</a:t>
             </a:r>
           </a:p>
         </p:txBody>
@@ -5309,7 +5319,7 @@
     </p:spTree>
     <p:extLst>
       <p:ext uri="{BB962C8B-B14F-4D97-AF65-F5344CB8AC3E}">
-        <p14:creationId xmlns:p14="http://schemas.microsoft.com/office/powerpoint/2010/main" val="1850485288"/>
+        <p14:creationId xmlns:p14="http://schemas.microsoft.com/office/powerpoint/2010/main" val="1294595161"/>
       </p:ext>
     </p:extLst>
   </p:cSld>
@@ -5340,7 +5350,7 @@
           <p:cNvPr id="8" name="">
             <a:extLst xmlns:a="http://schemas.openxmlformats.org/drawingml/2006/main">
               <a:ext uri="{FF2B5EF4-FFF2-40B4-BE49-F238E27FC236}">
-                <a16:creationId xmlns:a16="http://schemas.microsoft.com/office/drawing/2014/main" id="{BF08D184-D923-4526-933D-F9B7ECFE2811}"/>
+                <a16:creationId xmlns:a16="http://schemas.microsoft.com/office/drawing/2014/main" id="{EED00547-753F-4297-8134-A96746BB297C}"/>
               </a:ext>
             </a:extLst>
           </p:cNvPr>
@@ -5496,7 +5506,7 @@
           <p:cNvPr id="2" name="">
             <a:extLst xmlns:a="http://schemas.openxmlformats.org/drawingml/2006/main">
               <a:ext uri="{FF2B5EF4-FFF2-40B4-BE49-F238E27FC236}">
-                <a16:creationId xmlns:a16="http://schemas.microsoft.com/office/drawing/2014/main" id="{DEA67991-AC46-4611-8107-CBD32547CA8C}"/>
+                <a16:creationId xmlns:a16="http://schemas.microsoft.com/office/drawing/2014/main" id="{2E2A64F2-57D0-46A9-BA66-F1F6F20F93EE}"/>
               </a:ext>
             </a:extLst>
           </p:cNvPr>
@@ -5652,7 +5662,7 @@
           <p:cNvPr id="3" name="">
             <a:extLst xmlns:a="http://schemas.openxmlformats.org/drawingml/2006/main">
               <a:ext uri="{FF2B5EF4-FFF2-40B4-BE49-F238E27FC236}">
-                <a16:creationId xmlns:a16="http://schemas.microsoft.com/office/drawing/2014/main" id="{45C81D0E-714A-4391-B568-9A76A8B488B2}"/>
+                <a16:creationId xmlns:a16="http://schemas.microsoft.com/office/drawing/2014/main" id="{731D9DA2-8BF3-4BD6-8701-8843F505559C}"/>
               </a:ext>
             </a:extLst>
           </p:cNvPr>
@@ -5808,7 +5818,7 @@
           <p:cNvPr id="4" name="">
             <a:extLst xmlns:a="http://schemas.openxmlformats.org/drawingml/2006/main">
               <a:ext uri="{FF2B5EF4-FFF2-40B4-BE49-F238E27FC236}">
-                <a16:creationId xmlns:a16="http://schemas.microsoft.com/office/drawing/2014/main" id="{9BDEF716-A03C-4129-9B2D-CFEB213ACE3C}"/>
+                <a16:creationId xmlns:a16="http://schemas.microsoft.com/office/drawing/2014/main" id="{E8FD9D5D-9AB9-40F5-94E4-4D1820001EBC}"/>
               </a:ext>
             </a:extLst>
           </p:cNvPr>
@@ -5964,7 +5974,7 @@
           <p:cNvPr id="5" name="">
             <a:extLst xmlns:a="http://schemas.openxmlformats.org/drawingml/2006/main">
               <a:ext uri="{FF2B5EF4-FFF2-40B4-BE49-F238E27FC236}">
-                <a16:creationId xmlns:a16="http://schemas.microsoft.com/office/drawing/2014/main" id="{F6F1FD76-57E4-4FA1-B0D9-196F493CD542}"/>
+                <a16:creationId xmlns:a16="http://schemas.microsoft.com/office/drawing/2014/main" id="{A910A4B1-9A5F-4727-8507-EC3F222334DA}"/>
               </a:ext>
             </a:extLst>
           </p:cNvPr>
@@ -6166,7 +6176,7 @@
           <p:cNvPr id="6" name="">
             <a:extLst xmlns:a="http://schemas.openxmlformats.org/drawingml/2006/main">
               <a:ext uri="{FF2B5EF4-FFF2-40B4-BE49-F238E27FC236}">
-                <a16:creationId xmlns:a16="http://schemas.microsoft.com/office/drawing/2014/main" id="{AD93FAD3-1A62-4DB7-8F24-7292583E35ED}"/>
+                <a16:creationId xmlns:a16="http://schemas.microsoft.com/office/drawing/2014/main" id="{3074A0B4-A4F8-4C2F-ABCE-887D49F11F9E}"/>
               </a:ext>
             </a:extLst>
           </p:cNvPr>
@@ -6345,7 +6355,7 @@
           <p:cNvPr id="7" name="">
             <a:extLst xmlns:a="http://schemas.openxmlformats.org/drawingml/2006/main">
               <a:ext uri="{FF2B5EF4-FFF2-40B4-BE49-F238E27FC236}">
-                <a16:creationId xmlns:a16="http://schemas.microsoft.com/office/drawing/2014/main" id="{2D572752-2F4F-4C7E-998D-7EDB063C70D0}"/>
+                <a16:creationId xmlns:a16="http://schemas.microsoft.com/office/drawing/2014/main" id="{AADB9D63-CA44-4B1E-A8AB-C1F7A5170D43}"/>
               </a:ext>
             </a:extLst>
           </p:cNvPr>
@@ -6355,8 +6365,8 @@
           <p:nvPr/>
         </p:nvPicPr>
         <p:blipFill>
-          <a:blip xmlns:r="http://schemas.openxmlformats.org/officeDocument/2006/relationships" xmlns:a="http://schemas.openxmlformats.org/drawingml/2006/main" r:embed="R62ed3ab7dac447cf"/>
-          <a:srcRect xmlns:a="http://schemas.openxmlformats.org/drawingml/2006/main" l="20700" t="15000" r="1600" b="60000"/>
+          <a:blip xmlns:r="http://schemas.openxmlformats.org/officeDocument/2006/relationships" xmlns:a="http://schemas.openxmlformats.org/drawingml/2006/main" r:embed="Rfe884b0b8f8c4685"/>
+          <a:srcRect xmlns:a="http://schemas.openxmlformats.org/drawingml/2006/main" l="38194" t="30909" r="3472" b="28455"/>
           <a:stretch xmlns:a="http://schemas.openxmlformats.org/drawingml/2006/main"/>
         </p:blipFill>
         <p:spPr>
@@ -6372,7 +6382,7 @@
     </p:spTree>
     <p:extLst>
       <p:ext uri="{BB962C8B-B14F-4D97-AF65-F5344CB8AC3E}">
-        <p14:creationId xmlns:p14="http://schemas.microsoft.com/office/powerpoint/2010/main" val="1556459568"/>
+        <p14:creationId xmlns:p14="http://schemas.microsoft.com/office/powerpoint/2010/main" val="1523703311"/>
       </p:ext>
     </p:extLst>
   </p:cSld>
@@ -6403,7 +6413,7 @@
           <p:cNvPr id="18" name="">
             <a:extLst xmlns:a="http://schemas.openxmlformats.org/drawingml/2006/main">
               <a:ext uri="{FF2B5EF4-FFF2-40B4-BE49-F238E27FC236}">
-                <a16:creationId xmlns:a16="http://schemas.microsoft.com/office/drawing/2014/main" id="{DA93DFAE-11D3-4636-9149-62B93378EAF9}"/>
+                <a16:creationId xmlns:a16="http://schemas.microsoft.com/office/drawing/2014/main" id="{50A15135-2442-4C9F-AA3A-62A09975A7BF}"/>
               </a:ext>
             </a:extLst>
           </p:cNvPr>
@@ -6559,7 +6569,7 @@
           <p:cNvPr id="2" name="">
             <a:extLst xmlns:a="http://schemas.openxmlformats.org/drawingml/2006/main">
               <a:ext uri="{FF2B5EF4-FFF2-40B4-BE49-F238E27FC236}">
-                <a16:creationId xmlns:a16="http://schemas.microsoft.com/office/drawing/2014/main" id="{46FFE6C6-2F56-4D0A-9639-22769DBDDF6A}"/>
+                <a16:creationId xmlns:a16="http://schemas.microsoft.com/office/drawing/2014/main" id="{A6ED9EBE-B125-4092-8401-0EF9E8314C03}"/>
               </a:ext>
             </a:extLst>
           </p:cNvPr>
@@ -6715,7 +6725,7 @@
           <p:cNvPr id="3" name="">
             <a:extLst xmlns:a="http://schemas.openxmlformats.org/drawingml/2006/main">
               <a:ext uri="{FF2B5EF4-FFF2-40B4-BE49-F238E27FC236}">
-                <a16:creationId xmlns:a16="http://schemas.microsoft.com/office/drawing/2014/main" id="{521B26C5-E849-4072-ABBF-8AF1ED03CB1D}"/>
+                <a16:creationId xmlns:a16="http://schemas.microsoft.com/office/drawing/2014/main" id="{511BAA67-CBE1-4F33-B5D0-72F1FEFD2CDE}"/>
               </a:ext>
             </a:extLst>
           </p:cNvPr>
@@ -6871,7 +6881,7 @@
           <p:cNvPr id="4" name="">
             <a:extLst xmlns:a="http://schemas.openxmlformats.org/drawingml/2006/main">
               <a:ext uri="{FF2B5EF4-FFF2-40B4-BE49-F238E27FC236}">
-                <a16:creationId xmlns:a16="http://schemas.microsoft.com/office/drawing/2014/main" id="{E33F9D51-8069-4A2D-BBB7-BDEBA308BE4D}"/>
+                <a16:creationId xmlns:a16="http://schemas.microsoft.com/office/drawing/2014/main" id="{A0281152-FC63-4F06-B4D5-BBD8EF23541D}"/>
               </a:ext>
             </a:extLst>
           </p:cNvPr>
@@ -7027,7 +7037,7 @@
           <p:cNvPr id="5" name="">
             <a:extLst xmlns:a="http://schemas.openxmlformats.org/drawingml/2006/main">
               <a:ext uri="{FF2B5EF4-FFF2-40B4-BE49-F238E27FC236}">
-                <a16:creationId xmlns:a16="http://schemas.microsoft.com/office/drawing/2014/main" id="{516A9610-3AA0-47DD-BA75-DB911FBDF732}"/>
+                <a16:creationId xmlns:a16="http://schemas.microsoft.com/office/drawing/2014/main" id="{7721C835-7DAE-4F69-8FD2-C6D28E863048}"/>
               </a:ext>
             </a:extLst>
           </p:cNvPr>
@@ -7183,7 +7193,7 @@
           <p:cNvPr id="6" name="">
             <a:extLst xmlns:a="http://schemas.openxmlformats.org/drawingml/2006/main">
               <a:ext uri="{FF2B5EF4-FFF2-40B4-BE49-F238E27FC236}">
-                <a16:creationId xmlns:a16="http://schemas.microsoft.com/office/drawing/2014/main" id="{597A55D0-CD14-49EF-80C2-5CCC62EC0CA9}"/>
+                <a16:creationId xmlns:a16="http://schemas.microsoft.com/office/drawing/2014/main" id="{10209C9A-72A1-427A-94A6-1DDF4120771A}"/>
               </a:ext>
             </a:extLst>
           </p:cNvPr>
@@ -7339,7 +7349,7 @@
           <p:cNvPr id="7" name="">
             <a:extLst xmlns:a="http://schemas.openxmlformats.org/drawingml/2006/main">
               <a:ext uri="{FF2B5EF4-FFF2-40B4-BE49-F238E27FC236}">
-                <a16:creationId xmlns:a16="http://schemas.microsoft.com/office/drawing/2014/main" id="{C1217F77-3E56-439A-BABA-82101D95A554}"/>
+                <a16:creationId xmlns:a16="http://schemas.microsoft.com/office/drawing/2014/main" id="{EBBF3CE1-55DF-413B-8040-3070BCCEFAD9}"/>
               </a:ext>
             </a:extLst>
           </p:cNvPr>
@@ -7485,7 +7495,7 @@
                 <a:ea typeface="Arial"/>
                 <a:cs typeface="Arial"/>
               </a:rPr>
-              <a:t>Choose the evidence needed for the question.</a:t>
+              <a:t>Manifest + telemetry leave the case unresolved.</a:t>
             </a:r>
           </a:p>
         </p:txBody>
@@ -7495,7 +7505,7 @@
           <p:cNvPr id="8" name="">
             <a:extLst xmlns:a="http://schemas.openxmlformats.org/drawingml/2006/main">
               <a:ext uri="{FF2B5EF4-FFF2-40B4-BE49-F238E27FC236}">
-                <a16:creationId xmlns:a16="http://schemas.microsoft.com/office/drawing/2014/main" id="{762E2A6A-C612-4752-B658-6ED2F78AC11C}"/>
+                <a16:creationId xmlns:a16="http://schemas.microsoft.com/office/drawing/2014/main" id="{27B11871-2D19-4FFC-A2EF-85E810EFEBB3}"/>
               </a:ext>
             </a:extLst>
           </p:cNvPr>
@@ -7651,7 +7661,7 @@
           <p:cNvPr id="9" name="">
             <a:extLst xmlns:a="http://schemas.openxmlformats.org/drawingml/2006/main">
               <a:ext uri="{FF2B5EF4-FFF2-40B4-BE49-F238E27FC236}">
-                <a16:creationId xmlns:a16="http://schemas.microsoft.com/office/drawing/2014/main" id="{D9D535DA-77EE-49A2-A83D-D22BE058EDF6}"/>
+                <a16:creationId xmlns:a16="http://schemas.microsoft.com/office/drawing/2014/main" id="{AD2A3B4C-6DA5-45E2-8F9F-ACB7B2FD86CB}"/>
               </a:ext>
             </a:extLst>
           </p:cNvPr>
@@ -7807,7 +7817,7 @@
           <p:cNvPr id="10" name="">
             <a:extLst xmlns:a="http://schemas.openxmlformats.org/drawingml/2006/main">
               <a:ext uri="{FF2B5EF4-FFF2-40B4-BE49-F238E27FC236}">
-                <a16:creationId xmlns:a16="http://schemas.microsoft.com/office/drawing/2014/main" id="{74AC8137-16A8-4B91-8A88-5E9F5D9E9350}"/>
+                <a16:creationId xmlns:a16="http://schemas.microsoft.com/office/drawing/2014/main" id="{7ABF61B5-485A-401D-BF77-A68421624079}"/>
               </a:ext>
             </a:extLst>
           </p:cNvPr>
@@ -7953,7 +7963,7 @@
                 <a:ea typeface="Arial"/>
                 <a:cs typeface="Arial"/>
               </a:rPr>
-              <a:t>Query governed sources; build World Model context.</a:t>
+              <a:t>Consume governed rows through World Model context.</a:t>
             </a:r>
           </a:p>
         </p:txBody>
@@ -7963,7 +7973,7 @@
           <p:cNvPr id="11" name="">
             <a:extLst xmlns:a="http://schemas.openxmlformats.org/drawingml/2006/main">
               <a:ext uri="{FF2B5EF4-FFF2-40B4-BE49-F238E27FC236}">
-                <a16:creationId xmlns:a16="http://schemas.microsoft.com/office/drawing/2014/main" id="{98A7FD02-261D-4AAD-B6D6-BDEA619F077B}"/>
+                <a16:creationId xmlns:a16="http://schemas.microsoft.com/office/drawing/2014/main" id="{6E94D902-F5A1-4520-AF96-8926B8F1400E}"/>
               </a:ext>
             </a:extLst>
           </p:cNvPr>
@@ -8119,7 +8129,7 @@
           <p:cNvPr id="12" name="">
             <a:extLst xmlns:a="http://schemas.openxmlformats.org/drawingml/2006/main">
               <a:ext uri="{FF2B5EF4-FFF2-40B4-BE49-F238E27FC236}">
-                <a16:creationId xmlns:a16="http://schemas.microsoft.com/office/drawing/2014/main" id="{FCB15339-2500-4580-AC1F-F60A7359EB7C}"/>
+                <a16:creationId xmlns:a16="http://schemas.microsoft.com/office/drawing/2014/main" id="{00C6BA56-7AC1-449D-B8C4-C07C473A7D5F}"/>
               </a:ext>
             </a:extLst>
           </p:cNvPr>
@@ -8265,7 +8275,7 @@
                 <a:ea typeface="Arial"/>
                 <a:cs typeface="Arial"/>
               </a:rPr>
-              <a:t>Challenge the answer</a:t>
+              <a:t>Retrieve missing evidence</a:t>
             </a:r>
           </a:p>
         </p:txBody>
@@ -8275,7 +8285,7 @@
           <p:cNvPr id="13" name="">
             <a:extLst xmlns:a="http://schemas.openxmlformats.org/drawingml/2006/main">
               <a:ext uri="{FF2B5EF4-FFF2-40B4-BE49-F238E27FC236}">
-                <a16:creationId xmlns:a16="http://schemas.microsoft.com/office/drawing/2014/main" id="{1872D2CD-EC14-4A78-AEE4-730B5C1930E7}"/>
+                <a16:creationId xmlns:a16="http://schemas.microsoft.com/office/drawing/2014/main" id="{DC991361-6994-4B27-B643-FAEA5818C861}"/>
               </a:ext>
             </a:extLst>
           </p:cNvPr>
@@ -8421,7 +8431,7 @@
                 <a:ea typeface="Arial"/>
                 <a:cs typeface="Arial"/>
               </a:rPr>
-              <a:t>Request missing evidence; withhold a key assumption.</a:t>
+              <a:t>Critic requests incidents + calibration from Zetaris.</a:t>
             </a:r>
           </a:p>
         </p:txBody>
@@ -8431,7 +8441,7 @@
           <p:cNvPr id="14" name="">
             <a:extLst xmlns:a="http://schemas.openxmlformats.org/drawingml/2006/main">
               <a:ext uri="{FF2B5EF4-FFF2-40B4-BE49-F238E27FC236}">
-                <a16:creationId xmlns:a16="http://schemas.microsoft.com/office/drawing/2014/main" id="{44247662-7A75-4A2C-A1AA-72A3D9C2AD50}"/>
+                <a16:creationId xmlns:a16="http://schemas.microsoft.com/office/drawing/2014/main" id="{2B2F057A-E949-4D12-AA7F-755E378522C9}"/>
               </a:ext>
             </a:extLst>
           </p:cNvPr>
@@ -8587,7 +8597,7 @@
           <p:cNvPr id="15" name="">
             <a:extLst xmlns:a="http://schemas.openxmlformats.org/drawingml/2006/main">
               <a:ext uri="{FF2B5EF4-FFF2-40B4-BE49-F238E27FC236}">
-                <a16:creationId xmlns:a16="http://schemas.microsoft.com/office/drawing/2014/main" id="{C4300661-36D3-4A38-8618-A77CCB2B6E60}"/>
+                <a16:creationId xmlns:a16="http://schemas.microsoft.com/office/drawing/2014/main" id="{431D4ACD-C8CD-4D33-9668-BF8D29B11ED6}"/>
               </a:ext>
             </a:extLst>
           </p:cNvPr>
@@ -8733,7 +8743,7 @@
                 <a:ea typeface="Arial"/>
                 <a:cs typeface="Arial"/>
               </a:rPr>
-              <a:t>Recompute and explain</a:t>
+              <a:t>Recompute and challenge</a:t>
             </a:r>
           </a:p>
         </p:txBody>
@@ -8743,7 +8753,7 @@
           <p:cNvPr id="16" name="">
             <a:extLst xmlns:a="http://schemas.openxmlformats.org/drawingml/2006/main">
               <a:ext uri="{FF2B5EF4-FFF2-40B4-BE49-F238E27FC236}">
-                <a16:creationId xmlns:a16="http://schemas.microsoft.com/office/drawing/2014/main" id="{7B9CE440-CF70-4BAC-B307-68238ED972E0}"/>
+                <a16:creationId xmlns:a16="http://schemas.microsoft.com/office/drawing/2014/main" id="{F60B7D70-B88E-470A-9872-C12DF6D84E12}"/>
               </a:ext>
             </a:extLst>
           </p:cNvPr>
@@ -8889,7 +8899,7 @@
                 <a:ea typeface="Arial"/>
                 <a:cs typeface="Arial"/>
               </a:rPr>
-              <a:t>Return supported findings, citations and next actions.</a:t>
+              <a:t>Sensor bias; withholding calibration restores abstention.</a:t>
             </a:r>
           </a:p>
         </p:txBody>
@@ -8899,7 +8909,7 @@
           <p:cNvPr id="17" name="">
             <a:extLst xmlns:a="http://schemas.openxmlformats.org/drawingml/2006/main">
               <a:ext uri="{FF2B5EF4-FFF2-40B4-BE49-F238E27FC236}">
-                <a16:creationId xmlns:a16="http://schemas.microsoft.com/office/drawing/2014/main" id="{FF68A1AC-988F-4EAD-B5AB-2EF4DA4B87FC}"/>
+                <a16:creationId xmlns:a16="http://schemas.microsoft.com/office/drawing/2014/main" id="{8F2400EF-5350-442D-BB01-1F15E59AD796}"/>
               </a:ext>
             </a:extLst>
           </p:cNvPr>
@@ -9045,7 +9055,7 @@
                 <a:ea typeface="Arial"/>
                 <a:cs typeface="Arial"/>
               </a:rPr>
-              <a:t>BOUNDED LIVE PATH: 3 MODEL CALLS · 4 UNIQUE SQL READS · 5 MINUTES</a:t>
+              <a:t>VERIFIED LIVE: 3 MODEL CALLS / 4 SQL READS / 46 EVIDENCE RECORDS</a:t>
             </a:r>
           </a:p>
         </p:txBody>
@@ -9053,7 +9063,7 @@
     </p:spTree>
     <p:extLst>
       <p:ext uri="{BB962C8B-B14F-4D97-AF65-F5344CB8AC3E}">
-        <p14:creationId xmlns:p14="http://schemas.microsoft.com/office/powerpoint/2010/main" val="2103521182"/>
+        <p14:creationId xmlns:p14="http://schemas.microsoft.com/office/powerpoint/2010/main" val="633722212"/>
       </p:ext>
     </p:extLst>
   </p:cSld>
@@ -9084,7 +9094,7 @@
           <p:cNvPr id="11" name="">
             <a:extLst xmlns:a="http://schemas.openxmlformats.org/drawingml/2006/main">
               <a:ext uri="{FF2B5EF4-FFF2-40B4-BE49-F238E27FC236}">
-                <a16:creationId xmlns:a16="http://schemas.microsoft.com/office/drawing/2014/main" id="{D5619D68-71D1-4B11-9747-6569D7D36681}"/>
+                <a16:creationId xmlns:a16="http://schemas.microsoft.com/office/drawing/2014/main" id="{946AF694-8679-4D05-9908-ECF1BE5B18D9}"/>
               </a:ext>
             </a:extLst>
           </p:cNvPr>
@@ -9240,7 +9250,7 @@
           <p:cNvPr id="2" name="">
             <a:extLst xmlns:a="http://schemas.openxmlformats.org/drawingml/2006/main">
               <a:ext uri="{FF2B5EF4-FFF2-40B4-BE49-F238E27FC236}">
-                <a16:creationId xmlns:a16="http://schemas.microsoft.com/office/drawing/2014/main" id="{F8F3ACAB-0FA3-48B4-9489-0C374B56CF4F}"/>
+                <a16:creationId xmlns:a16="http://schemas.microsoft.com/office/drawing/2014/main" id="{913A067A-C033-4944-A8DE-AA28E1FDC882}"/>
               </a:ext>
             </a:extLst>
           </p:cNvPr>
@@ -9396,7 +9406,7 @@
           <p:cNvPr id="3" name="">
             <a:extLst xmlns:a="http://schemas.openxmlformats.org/drawingml/2006/main">
               <a:ext uri="{FF2B5EF4-FFF2-40B4-BE49-F238E27FC236}">
-                <a16:creationId xmlns:a16="http://schemas.microsoft.com/office/drawing/2014/main" id="{3D8ECD10-B26D-499B-9A8C-3EEB7C98F540}"/>
+                <a16:creationId xmlns:a16="http://schemas.microsoft.com/office/drawing/2014/main" id="{8CB16098-3A02-4674-B6C5-4D6E19F23B29}"/>
               </a:ext>
             </a:extLst>
           </p:cNvPr>
@@ -9552,7 +9562,7 @@
           <p:cNvPr id="4" name="">
             <a:extLst xmlns:a="http://schemas.openxmlformats.org/drawingml/2006/main">
               <a:ext uri="{FF2B5EF4-FFF2-40B4-BE49-F238E27FC236}">
-                <a16:creationId xmlns:a16="http://schemas.microsoft.com/office/drawing/2014/main" id="{3B6197C0-54F0-4688-86C8-CCF9AD7B29BD}"/>
+                <a16:creationId xmlns:a16="http://schemas.microsoft.com/office/drawing/2014/main" id="{135A0C0A-AED2-4DB5-9092-631855BA8671}"/>
               </a:ext>
             </a:extLst>
           </p:cNvPr>
@@ -9708,7 +9718,7 @@
           <p:cNvPr id="5" name="">
             <a:extLst xmlns:a="http://schemas.openxmlformats.org/drawingml/2006/main">
               <a:ext uri="{FF2B5EF4-FFF2-40B4-BE49-F238E27FC236}">
-                <a16:creationId xmlns:a16="http://schemas.microsoft.com/office/drawing/2014/main" id="{72A30876-0DA0-466D-B46F-D83C621B82DE}"/>
+                <a16:creationId xmlns:a16="http://schemas.microsoft.com/office/drawing/2014/main" id="{3D22E459-3F1D-4C8F-B429-D282DD9E7987}"/>
               </a:ext>
             </a:extLst>
           </p:cNvPr>
@@ -9864,7 +9874,7 @@
           <p:cNvPr id="6" name="">
             <a:extLst xmlns:a="http://schemas.openxmlformats.org/drawingml/2006/main">
               <a:ext uri="{FF2B5EF4-FFF2-40B4-BE49-F238E27FC236}">
-                <a16:creationId xmlns:a16="http://schemas.microsoft.com/office/drawing/2014/main" id="{01DABDBC-2115-4660-BC5C-7C316E82A32E}"/>
+                <a16:creationId xmlns:a16="http://schemas.microsoft.com/office/drawing/2014/main" id="{775BC808-8FF8-4B06-B60C-1DB38FCFA159}"/>
               </a:ext>
             </a:extLst>
           </p:cNvPr>
@@ -10089,7 +10099,7 @@
           <p:cNvPr id="7" name="">
             <a:extLst xmlns:a="http://schemas.openxmlformats.org/drawingml/2006/main">
               <a:ext uri="{FF2B5EF4-FFF2-40B4-BE49-F238E27FC236}">
-                <a16:creationId xmlns:a16="http://schemas.microsoft.com/office/drawing/2014/main" id="{4008D4FF-7D33-418A-9A1A-F9AED3A62AE2}"/>
+                <a16:creationId xmlns:a16="http://schemas.microsoft.com/office/drawing/2014/main" id="{1FA20470-0E97-4084-8927-E5E6D193F94F}"/>
               </a:ext>
             </a:extLst>
           </p:cNvPr>
@@ -10245,7 +10255,7 @@
           <p:cNvPr id="8" name="">
             <a:extLst xmlns:a="http://schemas.openxmlformats.org/drawingml/2006/main">
               <a:ext uri="{FF2B5EF4-FFF2-40B4-BE49-F238E27FC236}">
-                <a16:creationId xmlns:a16="http://schemas.microsoft.com/office/drawing/2014/main" id="{D70B2644-A071-4DB7-8EC8-AA574BB1749D}"/>
+                <a16:creationId xmlns:a16="http://schemas.microsoft.com/office/drawing/2014/main" id="{C6650D00-E91E-467D-9F03-BE57B375C02D}"/>
               </a:ext>
             </a:extLst>
           </p:cNvPr>
@@ -10401,7 +10411,7 @@
           <p:cNvPr id="9" name="">
             <a:extLst xmlns:a="http://schemas.openxmlformats.org/drawingml/2006/main">
               <a:ext uri="{FF2B5EF4-FFF2-40B4-BE49-F238E27FC236}">
-                <a16:creationId xmlns:a16="http://schemas.microsoft.com/office/drawing/2014/main" id="{D34CA6DF-3358-481B-A579-E1EDEB04B851}"/>
+                <a16:creationId xmlns:a16="http://schemas.microsoft.com/office/drawing/2014/main" id="{2A383637-CC4C-490B-BEA0-328051F8A3AE}"/>
               </a:ext>
             </a:extLst>
           </p:cNvPr>
@@ -10626,7 +10636,7 @@
           <p:cNvPr id="10" name="">
             <a:extLst xmlns:a="http://schemas.openxmlformats.org/drawingml/2006/main">
               <a:ext uri="{FF2B5EF4-FFF2-40B4-BE49-F238E27FC236}">
-                <a16:creationId xmlns:a16="http://schemas.microsoft.com/office/drawing/2014/main" id="{0A211D2D-0633-40AB-8E1F-121EE07763AC}"/>
+                <a16:creationId xmlns:a16="http://schemas.microsoft.com/office/drawing/2014/main" id="{196FE582-7229-4971-ADBC-80FB33E7C438}"/>
               </a:ext>
             </a:extLst>
           </p:cNvPr>
@@ -10780,7 +10790,7 @@
     </p:spTree>
     <p:extLst>
       <p:ext uri="{BB962C8B-B14F-4D97-AF65-F5344CB8AC3E}">
-        <p14:creationId xmlns:p14="http://schemas.microsoft.com/office/powerpoint/2010/main" val="882506794"/>
+        <p14:creationId xmlns:p14="http://schemas.microsoft.com/office/powerpoint/2010/main" val="1667958328"/>
       </p:ext>
     </p:extLst>
   </p:cSld>
@@ -10811,7 +10821,7 @@
           <p:cNvPr id="7" name="">
             <a:extLst xmlns:a="http://schemas.openxmlformats.org/drawingml/2006/main">
               <a:ext uri="{FF2B5EF4-FFF2-40B4-BE49-F238E27FC236}">
-                <a16:creationId xmlns:a16="http://schemas.microsoft.com/office/drawing/2014/main" id="{5CF6B9D0-FF81-4C92-ACC4-576E4DEBD5D8}"/>
+                <a16:creationId xmlns:a16="http://schemas.microsoft.com/office/drawing/2014/main" id="{D33EE9DD-21D9-43FB-9FC2-CFB206B52982}"/>
               </a:ext>
             </a:extLst>
           </p:cNvPr>
@@ -10967,7 +10977,7 @@
           <p:cNvPr id="2" name="">
             <a:extLst xmlns:a="http://schemas.openxmlformats.org/drawingml/2006/main">
               <a:ext uri="{FF2B5EF4-FFF2-40B4-BE49-F238E27FC236}">
-                <a16:creationId xmlns:a16="http://schemas.microsoft.com/office/drawing/2014/main" id="{34629493-0142-43CF-A114-349798D7E075}"/>
+                <a16:creationId xmlns:a16="http://schemas.microsoft.com/office/drawing/2014/main" id="{48945FF7-0BBA-49DD-B5A8-1D33A1AAD9AB}"/>
               </a:ext>
             </a:extLst>
           </p:cNvPr>
@@ -11123,7 +11133,7 @@
           <p:cNvPr id="3" name="">
             <a:extLst xmlns:a="http://schemas.openxmlformats.org/drawingml/2006/main">
               <a:ext uri="{FF2B5EF4-FFF2-40B4-BE49-F238E27FC236}">
-                <a16:creationId xmlns:a16="http://schemas.microsoft.com/office/drawing/2014/main" id="{80C7CC43-FCAC-42F7-AD07-97AD622FAE0C}"/>
+                <a16:creationId xmlns:a16="http://schemas.microsoft.com/office/drawing/2014/main" id="{DB42561E-7B7A-41A9-81FA-319967C8DF64}"/>
               </a:ext>
             </a:extLst>
           </p:cNvPr>
@@ -11279,7 +11289,7 @@
           <p:cNvPr id="4" name="">
             <a:extLst xmlns:a="http://schemas.openxmlformats.org/drawingml/2006/main">
               <a:ext uri="{FF2B5EF4-FFF2-40B4-BE49-F238E27FC236}">
-                <a16:creationId xmlns:a16="http://schemas.microsoft.com/office/drawing/2014/main" id="{ECC2215D-8C06-4110-A798-5B54E456DCCF}"/>
+                <a16:creationId xmlns:a16="http://schemas.microsoft.com/office/drawing/2014/main" id="{42FC797C-7259-49DB-88A9-52B3393CA695}"/>
               </a:ext>
             </a:extLst>
           </p:cNvPr>
@@ -11435,7 +11445,7 @@
           <p:cNvPr id="5" name="">
             <a:extLst xmlns:a="http://schemas.openxmlformats.org/drawingml/2006/main">
               <a:ext uri="{FF2B5EF4-FFF2-40B4-BE49-F238E27FC236}">
-                <a16:creationId xmlns:a16="http://schemas.microsoft.com/office/drawing/2014/main" id="{7780D5C1-CF75-4046-8059-22B6990FF68B}"/>
+                <a16:creationId xmlns:a16="http://schemas.microsoft.com/office/drawing/2014/main" id="{5AC57A62-21CB-42DF-8C77-1D8BD32B963F}"/>
               </a:ext>
             </a:extLst>
           </p:cNvPr>
@@ -11798,7 +11808,7 @@
                           <a:ea typeface="Arial"/>
                           <a:cs typeface="Arial"/>
                         </a:rPr>
-                        <a:t>Implementation present; execution pending</a:t>
+                        <a:t>Actual queries and DQ verified</a:t>
                       </a:r>
                     </a:p>
                   </a:txBody>
@@ -11914,7 +11924,7 @@
                           <a:ea typeface="Arial"/>
                           <a:cs typeface="Arial"/>
                         </a:rPr>
-                        <a:t>Runtime reachable; provider needed</a:t>
+                        <a:t>Three live model calls verified</a:t>
                       </a:r>
                     </a:p>
                   </a:txBody>
@@ -11952,7 +11962,7 @@
                           <a:ea typeface="Arial"/>
                           <a:cs typeface="Arial"/>
                         </a:rPr>
-                        <a:t>NVIDIA Nemotron</a:t>
+                        <a:t>NVIDIA (optional)</a:t>
                       </a:r>
                     </a:p>
                   </a:txBody>
@@ -11994,7 +12004,7 @@
                           <a:ea typeface="Arial"/>
                           <a:cs typeface="Arial"/>
                         </a:rPr>
-                        <a:t>Optional model through Nightshift</a:t>
+                        <a:t>No current contribution claimed</a:t>
                       </a:r>
                     </a:p>
                   </a:txBody>
@@ -12030,7 +12040,7 @@
                           <a:ea typeface="Arial"/>
                           <a:cs typeface="Arial"/>
                         </a:rPr>
-                        <a:t>No verified model request</a:t>
+                        <a:t>Not used: local Llama path</a:t>
                       </a:r>
                     </a:p>
                   </a:txBody>
@@ -12062,7 +12072,7 @@
           <p:cNvPr id="6" name="">
             <a:extLst xmlns:a="http://schemas.openxmlformats.org/drawingml/2006/main">
               <a:ext uri="{FF2B5EF4-FFF2-40B4-BE49-F238E27FC236}">
-                <a16:creationId xmlns:a16="http://schemas.microsoft.com/office/drawing/2014/main" id="{C50E680C-4C72-411C-A903-32D6353C7735}"/>
+                <a16:creationId xmlns:a16="http://schemas.microsoft.com/office/drawing/2014/main" id="{A2EE9C4E-3E5B-4501-B5DE-92AE88FA37CA}"/>
               </a:ext>
             </a:extLst>
           </p:cNvPr>
@@ -12216,7 +12226,7 @@
     </p:spTree>
     <p:extLst>
       <p:ext uri="{BB962C8B-B14F-4D97-AF65-F5344CB8AC3E}">
-        <p14:creationId xmlns:p14="http://schemas.microsoft.com/office/powerpoint/2010/main" val="2033010272"/>
+        <p14:creationId xmlns:p14="http://schemas.microsoft.com/office/powerpoint/2010/main" val="1300705813"/>
       </p:ext>
     </p:extLst>
   </p:cSld>
@@ -12247,7 +12257,7 @@
           <p:cNvPr id="11" name="">
             <a:extLst xmlns:a="http://schemas.openxmlformats.org/drawingml/2006/main">
               <a:ext uri="{FF2B5EF4-FFF2-40B4-BE49-F238E27FC236}">
-                <a16:creationId xmlns:a16="http://schemas.microsoft.com/office/drawing/2014/main" id="{D4FC26FA-4D9F-4C6B-B9CE-3F63F5FD776C}"/>
+                <a16:creationId xmlns:a16="http://schemas.microsoft.com/office/drawing/2014/main" id="{82CDC7A6-1CBA-42DB-810B-3FDF7F97A385}"/>
               </a:ext>
             </a:extLst>
           </p:cNvPr>
@@ -12403,7 +12413,7 @@
           <p:cNvPr id="2" name="">
             <a:extLst xmlns:a="http://schemas.openxmlformats.org/drawingml/2006/main">
               <a:ext uri="{FF2B5EF4-FFF2-40B4-BE49-F238E27FC236}">
-                <a16:creationId xmlns:a16="http://schemas.microsoft.com/office/drawing/2014/main" id="{4353C526-47AA-46FD-AB05-80EDB1EB31FD}"/>
+                <a16:creationId xmlns:a16="http://schemas.microsoft.com/office/drawing/2014/main" id="{2354503E-F87B-4794-A1A9-438AE1A3916F}"/>
               </a:ext>
             </a:extLst>
           </p:cNvPr>
@@ -12549,7 +12559,7 @@
                 <a:ea typeface="Arial"/>
                 <a:cs typeface="Arial"/>
               </a:rPr>
-              <a:t>Remove the evidence. Recompute the answer.</a:t>
+              <a:t>Withhold evidence. Test the answer.</a:t>
             </a:r>
           </a:p>
         </p:txBody>
@@ -12559,7 +12569,7 @@
           <p:cNvPr id="3" name="">
             <a:extLst xmlns:a="http://schemas.openxmlformats.org/drawingml/2006/main">
               <a:ext uri="{FF2B5EF4-FFF2-40B4-BE49-F238E27FC236}">
-                <a16:creationId xmlns:a16="http://schemas.microsoft.com/office/drawing/2014/main" id="{A6FD8469-A337-480D-BB34-9AF16AEBA80C}"/>
+                <a16:creationId xmlns:a16="http://schemas.microsoft.com/office/drawing/2014/main" id="{F5472EF4-B952-4D49-9974-FA5572777ED0}"/>
               </a:ext>
             </a:extLst>
           </p:cNvPr>
@@ -12715,7 +12725,7 @@
           <p:cNvPr id="4" name="">
             <a:extLst xmlns:a="http://schemas.openxmlformats.org/drawingml/2006/main">
               <a:ext uri="{FF2B5EF4-FFF2-40B4-BE49-F238E27FC236}">
-                <a16:creationId xmlns:a16="http://schemas.microsoft.com/office/drawing/2014/main" id="{8BC60B1F-5D58-4AA6-BCDB-C05DF97E3057}"/>
+                <a16:creationId xmlns:a16="http://schemas.microsoft.com/office/drawing/2014/main" id="{495D2505-8845-4418-81F8-0AD97DC545D5}"/>
               </a:ext>
             </a:extLst>
           </p:cNvPr>
@@ -12871,7 +12881,7 @@
           <p:cNvPr id="5" name="">
             <a:extLst xmlns:a="http://schemas.openxmlformats.org/drawingml/2006/main">
               <a:ext uri="{FF2B5EF4-FFF2-40B4-BE49-F238E27FC236}">
-                <a16:creationId xmlns:a16="http://schemas.microsoft.com/office/drawing/2014/main" id="{EEA94AF4-88D1-45E4-93E4-846A5920A957}"/>
+                <a16:creationId xmlns:a16="http://schemas.microsoft.com/office/drawing/2014/main" id="{89EB7076-4D82-4275-BAD2-DA342FBFCAED}"/>
               </a:ext>
             </a:extLst>
           </p:cNvPr>
@@ -13027,7 +13037,7 @@
           <p:cNvPr id="6" name="">
             <a:extLst xmlns:a="http://schemas.openxmlformats.org/drawingml/2006/main">
               <a:ext uri="{FF2B5EF4-FFF2-40B4-BE49-F238E27FC236}">
-                <a16:creationId xmlns:a16="http://schemas.microsoft.com/office/drawing/2014/main" id="{90AC2205-51CD-49E1-8F69-D6B46FB07E95}"/>
+                <a16:creationId xmlns:a16="http://schemas.microsoft.com/office/drawing/2014/main" id="{5DB19DC8-05DB-4236-8F6E-5D19F5205E1A}"/>
               </a:ext>
             </a:extLst>
           </p:cNvPr>
@@ -13183,7 +13193,7 @@
           <p:cNvPr id="7" name="">
             <a:extLst xmlns:a="http://schemas.openxmlformats.org/drawingml/2006/main">
               <a:ext uri="{FF2B5EF4-FFF2-40B4-BE49-F238E27FC236}">
-                <a16:creationId xmlns:a16="http://schemas.microsoft.com/office/drawing/2014/main" id="{0114ECFA-B7E9-4BDC-A3D1-1567E6A5069E}"/>
+                <a16:creationId xmlns:a16="http://schemas.microsoft.com/office/drawing/2014/main" id="{995FDD90-0991-4909-9BCA-01BE785C1E85}"/>
               </a:ext>
             </a:extLst>
           </p:cNvPr>
@@ -13362,7 +13372,7 @@
           <p:cNvPr id="8" name="">
             <a:extLst xmlns:a="http://schemas.openxmlformats.org/drawingml/2006/main">
               <a:ext uri="{FF2B5EF4-FFF2-40B4-BE49-F238E27FC236}">
-                <a16:creationId xmlns:a16="http://schemas.microsoft.com/office/drawing/2014/main" id="{1CF9D5D4-5967-461F-970D-BE95CAC35238}"/>
+                <a16:creationId xmlns:a16="http://schemas.microsoft.com/office/drawing/2014/main" id="{DC692A2C-3426-4A09-ADC3-220B4D55D53F}"/>
               </a:ext>
             </a:extLst>
           </p:cNvPr>
@@ -13518,7 +13528,7 @@
           <p:cNvPr id="9" name="">
             <a:extLst xmlns:a="http://schemas.openxmlformats.org/drawingml/2006/main">
               <a:ext uri="{FF2B5EF4-FFF2-40B4-BE49-F238E27FC236}">
-                <a16:creationId xmlns:a16="http://schemas.microsoft.com/office/drawing/2014/main" id="{A0DCB7A5-DA2B-4339-B006-FDAAEF18DB0C}"/>
+                <a16:creationId xmlns:a16="http://schemas.microsoft.com/office/drawing/2014/main" id="{76F7723C-191A-4D62-B7B7-B9247ACC487D}"/>
               </a:ext>
             </a:extLst>
           </p:cNvPr>
@@ -13697,7 +13707,7 @@
           <p:cNvPr id="10" name="">
             <a:extLst xmlns:a="http://schemas.openxmlformats.org/drawingml/2006/main">
               <a:ext uri="{FF2B5EF4-FFF2-40B4-BE49-F238E27FC236}">
-                <a16:creationId xmlns:a16="http://schemas.microsoft.com/office/drawing/2014/main" id="{7FD58F54-09CA-4026-8BB8-9129DF815987}"/>
+                <a16:creationId xmlns:a16="http://schemas.microsoft.com/office/drawing/2014/main" id="{BF98C681-476A-4A0C-82A2-B0702A4A6B01}"/>
               </a:ext>
             </a:extLst>
           </p:cNvPr>
@@ -13707,8 +13717,8 @@
           <p:nvPr/>
         </p:nvPicPr>
         <p:blipFill>
-          <a:blip xmlns:r="http://schemas.openxmlformats.org/officeDocument/2006/relationships" xmlns:a="http://schemas.openxmlformats.org/drawingml/2006/main" r:embed="R8de5d605cd1a4543"/>
-          <a:srcRect xmlns:a="http://schemas.openxmlformats.org/drawingml/2006/main" l="44000" t="37000" r="3000" b="35000"/>
+          <a:blip xmlns:r="http://schemas.openxmlformats.org/officeDocument/2006/relationships" xmlns:a="http://schemas.openxmlformats.org/drawingml/2006/main" r:embed="R2cea9780d32b4d9f"/>
+          <a:srcRect xmlns:a="http://schemas.openxmlformats.org/drawingml/2006/main" l="38194" t="42727" r="3472" b="14909"/>
           <a:stretch xmlns:a="http://schemas.openxmlformats.org/drawingml/2006/main"/>
         </p:blipFill>
         <p:spPr>
@@ -13724,7 +13734,7 @@
     </p:spTree>
     <p:extLst>
       <p:ext uri="{BB962C8B-B14F-4D97-AF65-F5344CB8AC3E}">
-        <p14:creationId xmlns:p14="http://schemas.microsoft.com/office/powerpoint/2010/main" val="547476953"/>
+        <p14:creationId xmlns:p14="http://schemas.microsoft.com/office/powerpoint/2010/main" val="885589811"/>
       </p:ext>
     </p:extLst>
   </p:cSld>
@@ -13755,7 +13765,7 @@
           <p:cNvPr id="8" name="">
             <a:extLst xmlns:a="http://schemas.openxmlformats.org/drawingml/2006/main">
               <a:ext uri="{FF2B5EF4-FFF2-40B4-BE49-F238E27FC236}">
-                <a16:creationId xmlns:a16="http://schemas.microsoft.com/office/drawing/2014/main" id="{714AE120-E44D-4901-B9E2-AB30E4BE8109}"/>
+                <a16:creationId xmlns:a16="http://schemas.microsoft.com/office/drawing/2014/main" id="{F4C956EB-D2A7-43B7-8A65-866CAFA0F17D}"/>
               </a:ext>
             </a:extLst>
           </p:cNvPr>
@@ -13911,7 +13921,7 @@
           <p:cNvPr id="2" name="">
             <a:extLst xmlns:a="http://schemas.openxmlformats.org/drawingml/2006/main">
               <a:ext uri="{FF2B5EF4-FFF2-40B4-BE49-F238E27FC236}">
-                <a16:creationId xmlns:a16="http://schemas.microsoft.com/office/drawing/2014/main" id="{C770F223-CDA6-4490-9000-5D0AAC5BC870}"/>
+                <a16:creationId xmlns:a16="http://schemas.microsoft.com/office/drawing/2014/main" id="{09289559-554B-40F3-9265-2F887E6D3882}"/>
               </a:ext>
             </a:extLst>
           </p:cNvPr>
@@ -14067,7 +14077,7 @@
           <p:cNvPr id="3" name="">
             <a:extLst xmlns:a="http://schemas.openxmlformats.org/drawingml/2006/main">
               <a:ext uri="{FF2B5EF4-FFF2-40B4-BE49-F238E27FC236}">
-                <a16:creationId xmlns:a16="http://schemas.microsoft.com/office/drawing/2014/main" id="{3CC5C434-4E1A-4224-B2C0-E497690463BD}"/>
+                <a16:creationId xmlns:a16="http://schemas.microsoft.com/office/drawing/2014/main" id="{06C1F422-4BA1-41AA-9348-518A076278B1}"/>
               </a:ext>
             </a:extLst>
           </p:cNvPr>
@@ -14223,7 +14233,7 @@
           <p:cNvPr id="4" name="">
             <a:extLst xmlns:a="http://schemas.openxmlformats.org/drawingml/2006/main">
               <a:ext uri="{FF2B5EF4-FFF2-40B4-BE49-F238E27FC236}">
-                <a16:creationId xmlns:a16="http://schemas.microsoft.com/office/drawing/2014/main" id="{FBC00C0B-D26A-4220-9870-AE5BF74E6BD1}"/>
+                <a16:creationId xmlns:a16="http://schemas.microsoft.com/office/drawing/2014/main" id="{3EBF2B31-DEC5-4AC4-A03D-A4815E8F7AF5}"/>
               </a:ext>
             </a:extLst>
           </p:cNvPr>
@@ -14379,7 +14389,7 @@
           <p:cNvPr id="5" name="">
             <a:extLst xmlns:a="http://schemas.openxmlformats.org/drawingml/2006/main">
               <a:ext uri="{FF2B5EF4-FFF2-40B4-BE49-F238E27FC236}">
-                <a16:creationId xmlns:a16="http://schemas.microsoft.com/office/drawing/2014/main" id="{4020C259-E460-48D4-986D-02DEA9762FBA}"/>
+                <a16:creationId xmlns:a16="http://schemas.microsoft.com/office/drawing/2014/main" id="{87EB2900-636B-48F4-8A80-66984A19AC99}"/>
               </a:ext>
             </a:extLst>
           </p:cNvPr>
@@ -15006,7 +15016,7 @@
           <p:cNvPr id="6" name="">
             <a:extLst xmlns:a="http://schemas.openxmlformats.org/drawingml/2006/main">
               <a:ext uri="{FF2B5EF4-FFF2-40B4-BE49-F238E27FC236}">
-                <a16:creationId xmlns:a16="http://schemas.microsoft.com/office/drawing/2014/main" id="{6F67EC3E-C288-4DA1-B300-4DEC81ECB1FB}"/>
+                <a16:creationId xmlns:a16="http://schemas.microsoft.com/office/drawing/2014/main" id="{C6BC4380-0B9F-42D2-A917-6358DA5D786B}"/>
               </a:ext>
             </a:extLst>
           </p:cNvPr>
@@ -15152,7 +15162,7 @@
                 <a:ea typeface="Arial"/>
                 <a:cs typeface="Arial"/>
               </a:rPr>
-              <a:t>14 local tests passed</a:t>
+              <a:t>16 local tests passed</a:t>
             </a:r>
           </a:p>
         </p:txBody>
@@ -15162,7 +15172,7 @@
           <p:cNvPr id="7" name="">
             <a:extLst xmlns:a="http://schemas.openxmlformats.org/drawingml/2006/main">
               <a:ext uri="{FF2B5EF4-FFF2-40B4-BE49-F238E27FC236}">
-                <a16:creationId xmlns:a16="http://schemas.microsoft.com/office/drawing/2014/main" id="{CA668373-58C3-42C3-8C3F-5193412CB6F7}"/>
+                <a16:creationId xmlns:a16="http://schemas.microsoft.com/office/drawing/2014/main" id="{2447BA3A-92CE-443E-BA19-36C14AE9C6AB}"/>
               </a:ext>
             </a:extLst>
           </p:cNvPr>
@@ -15316,7 +15326,7 @@
     </p:spTree>
     <p:extLst>
       <p:ext uri="{BB962C8B-B14F-4D97-AF65-F5344CB8AC3E}">
-        <p14:creationId xmlns:p14="http://schemas.microsoft.com/office/powerpoint/2010/main" val="943939779"/>
+        <p14:creationId xmlns:p14="http://schemas.microsoft.com/office/powerpoint/2010/main" val="1988472094"/>
       </p:ext>
     </p:extLst>
   </p:cSld>
@@ -15347,7 +15357,7 @@
           <p:cNvPr id="9" name="">
             <a:extLst xmlns:a="http://schemas.openxmlformats.org/drawingml/2006/main">
               <a:ext uri="{FF2B5EF4-FFF2-40B4-BE49-F238E27FC236}">
-                <a16:creationId xmlns:a16="http://schemas.microsoft.com/office/drawing/2014/main" id="{F5595ABE-0EDD-450A-A40C-02BF233E4455}"/>
+                <a16:creationId xmlns:a16="http://schemas.microsoft.com/office/drawing/2014/main" id="{1F566839-ED9A-4F67-92BF-B3B0F383DDE7}"/>
               </a:ext>
             </a:extLst>
           </p:cNvPr>
@@ -15503,7 +15513,7 @@
           <p:cNvPr id="2" name="">
             <a:extLst xmlns:a="http://schemas.openxmlformats.org/drawingml/2006/main">
               <a:ext uri="{FF2B5EF4-FFF2-40B4-BE49-F238E27FC236}">
-                <a16:creationId xmlns:a16="http://schemas.microsoft.com/office/drawing/2014/main" id="{671C443C-1246-4B06-A062-8A5229932C93}"/>
+                <a16:creationId xmlns:a16="http://schemas.microsoft.com/office/drawing/2014/main" id="{2755404E-0623-498B-9EE5-00B1C2C295EE}"/>
               </a:ext>
             </a:extLst>
           </p:cNvPr>
@@ -15659,7 +15669,7 @@
           <p:cNvPr id="3" name="">
             <a:extLst xmlns:a="http://schemas.openxmlformats.org/drawingml/2006/main">
               <a:ext uri="{FF2B5EF4-FFF2-40B4-BE49-F238E27FC236}">
-                <a16:creationId xmlns:a16="http://schemas.microsoft.com/office/drawing/2014/main" id="{4BE89509-EFC0-4FDB-B8DA-839B036EF67A}"/>
+                <a16:creationId xmlns:a16="http://schemas.microsoft.com/office/drawing/2014/main" id="{6021AC32-2815-4238-930C-38928E777224}"/>
               </a:ext>
             </a:extLst>
           </p:cNvPr>
@@ -15815,7 +15825,7 @@
           <p:cNvPr id="4" name="">
             <a:extLst xmlns:a="http://schemas.openxmlformats.org/drawingml/2006/main">
               <a:ext uri="{FF2B5EF4-FFF2-40B4-BE49-F238E27FC236}">
-                <a16:creationId xmlns:a16="http://schemas.microsoft.com/office/drawing/2014/main" id="{0A0953EF-04AB-4453-9662-8D3FCE15BFE1}"/>
+                <a16:creationId xmlns:a16="http://schemas.microsoft.com/office/drawing/2014/main" id="{631E330F-5439-4564-A5F2-18C71275D70E}"/>
               </a:ext>
             </a:extLst>
           </p:cNvPr>
@@ -15971,7 +15981,7 @@
           <p:cNvPr id="5" name="">
             <a:extLst xmlns:a="http://schemas.openxmlformats.org/drawingml/2006/main">
               <a:ext uri="{FF2B5EF4-FFF2-40B4-BE49-F238E27FC236}">
-                <a16:creationId xmlns:a16="http://schemas.microsoft.com/office/drawing/2014/main" id="{DCCF1E8B-1B28-4B63-AB8B-EC15B00C7C82}"/>
+                <a16:creationId xmlns:a16="http://schemas.microsoft.com/office/drawing/2014/main" id="{22A810E9-9185-445C-8C4F-BF75D5B0268E}"/>
               </a:ext>
             </a:extLst>
           </p:cNvPr>
@@ -16117,7 +16127,7 @@
                 <a:ea typeface="Arial"/>
                 <a:cs typeface="Arial"/>
               </a:rPr>
-              <a:t>01  Finish live integration receipts</a:t>
+              <a:t>01  Validate more unseen cases</a:t>
             </a:r>
           </a:p>
           <a:p xmlns:a="http://schemas.openxmlformats.org/drawingml/2006/main">
@@ -16173,7 +16183,7 @@
           <p:cNvPr id="6" name="">
             <a:extLst xmlns:a="http://schemas.openxmlformats.org/drawingml/2006/main">
               <a:ext uri="{FF2B5EF4-FFF2-40B4-BE49-F238E27FC236}">
-                <a16:creationId xmlns:a16="http://schemas.microsoft.com/office/drawing/2014/main" id="{5C1DC82D-2567-4ED6-A7A1-77D610D68D56}"/>
+                <a16:creationId xmlns:a16="http://schemas.microsoft.com/office/drawing/2014/main" id="{DD54FD74-9456-4C59-9587-357935FA18DC}"/>
               </a:ext>
             </a:extLst>
           </p:cNvPr>
@@ -16352,7 +16362,7 @@
           <p:cNvPr id="7" name="">
             <a:extLst xmlns:a="http://schemas.openxmlformats.org/drawingml/2006/main">
               <a:ext uri="{FF2B5EF4-FFF2-40B4-BE49-F238E27FC236}">
-                <a16:creationId xmlns:a16="http://schemas.microsoft.com/office/drawing/2014/main" id="{DF417013-93FF-4FCA-B2FE-813497103231}"/>
+                <a16:creationId xmlns:a16="http://schemas.microsoft.com/office/drawing/2014/main" id="{53D33567-C053-4664-9C81-9B1B19834047}"/>
               </a:ext>
             </a:extLst>
           </p:cNvPr>
@@ -16508,7 +16518,7 @@
           <p:cNvPr id="8" name="">
             <a:extLst xmlns:a="http://schemas.openxmlformats.org/drawingml/2006/main">
               <a:ext uri="{FF2B5EF4-FFF2-40B4-BE49-F238E27FC236}">
-                <a16:creationId xmlns:a16="http://schemas.microsoft.com/office/drawing/2014/main" id="{E05B9526-1773-4368-B2F9-1D154FB49E9E}"/>
+                <a16:creationId xmlns:a16="http://schemas.microsoft.com/office/drawing/2014/main" id="{C2598645-B188-4E5E-9548-7F04829B11B3}"/>
               </a:ext>
             </a:extLst>
           </p:cNvPr>
@@ -16662,7 +16672,7 @@
     </p:spTree>
     <p:extLst>
       <p:ext uri="{BB962C8B-B14F-4D97-AF65-F5344CB8AC3E}">
-        <p14:creationId xmlns:p14="http://schemas.microsoft.com/office/powerpoint/2010/main" val="155515427"/>
+        <p14:creationId xmlns:p14="http://schemas.microsoft.com/office/powerpoint/2010/main" val="1753397844"/>
       </p:ext>
     </p:extLst>
   </p:cSld>

</xml_diff>